<commit_message>
updates on ltl slides. Adding solutions to ltl exers
</commit_message>
<xml_diff>
--- a/slides/PV_ltl.pptx
+++ b/slides/PV_ltl.pptx
@@ -3639,7 +3639,7 @@
           <a:bodyPr/>
           <a:lstStyle/>
           <a:p>
-            <a:endParaRPr lang="nl-NL"/>
+            <a:endParaRPr lang="nl-NL" dirty="0"/>
           </a:p>
         </p:txBody>
       </p:sp>
@@ -47665,7 +47665,7 @@
                 <a:cs typeface="Arial" charset="0"/>
                 <a:sym typeface="Symbol"/>
               </a:rPr>
-              <a:t> turns out to be valid, then C will in the end fully constructed.</a:t>
+              <a:t> turns out to be valid, then C will in the end be fully constructed.</a:t>
             </a:r>
           </a:p>
           <a:p>
@@ -48180,7 +48180,7 @@
                 <a:cs typeface="Arial" charset="0"/>
                 <a:sym typeface="Symbol" pitchFamily="18" charset="2"/>
               </a:rPr>
-              <a:t>M</a:t>
+              <a:t>BM</a:t>
             </a:r>
             <a:r>
               <a:rPr lang="en-US" sz="2400" dirty="0">
@@ -48246,161 +48246,182 @@
               <a:t>  </a:t>
             </a:r>
             <a:r>
+              <a:rPr lang="en-US" sz="2400" i="1" dirty="0" err="1">
+                <a:cs typeface="Arial" charset="0"/>
+                <a:sym typeface="Symbol" pitchFamily="18" charset="2"/>
+              </a:rPr>
+              <a:t>next</a:t>
+            </a:r>
+            <a:r>
+              <a:rPr lang="en-US" sz="2400" baseline="-25000" dirty="0" err="1">
+                <a:cs typeface="Arial" charset="0"/>
+                <a:sym typeface="Symbol"/>
+              </a:rPr>
+              <a:t>B</a:t>
+            </a:r>
+            <a:r>
+              <a:rPr lang="en-US" sz="2400" baseline="-25000" dirty="0">
+                <a:cs typeface="Arial" charset="0"/>
+                <a:sym typeface="Symbol"/>
+              </a:rPr>
+              <a:t></a:t>
+            </a:r>
+            <a:r>
+              <a:rPr lang="en-US" sz="2400" dirty="0">
+                <a:cs typeface="Arial" charset="0"/>
+                <a:sym typeface="Symbol" pitchFamily="18" charset="2"/>
+              </a:rPr>
+              <a:t>(</a:t>
+            </a:r>
+            <a:r>
               <a:rPr lang="en-US" sz="2400" i="1" dirty="0">
                 <a:cs typeface="Arial" charset="0"/>
                 <a:sym typeface="Symbol" pitchFamily="18" charset="2"/>
               </a:rPr>
-              <a:t>next</a:t>
+              <a:t>u</a:t>
             </a:r>
             <a:r>
               <a:rPr lang="en-US" sz="2400" baseline="-25000" dirty="0">
                 <a:cs typeface="Arial" charset="0"/>
+                <a:sym typeface="Symbol" pitchFamily="18" charset="2"/>
+              </a:rPr>
+              <a:t>2</a:t>
+            </a:r>
+            <a:r>
+              <a:rPr lang="en-US" sz="2400" dirty="0">
+                <a:cs typeface="Arial" charset="0"/>
+                <a:sym typeface="Symbol" pitchFamily="18" charset="2"/>
+              </a:rPr>
+              <a:t>,</a:t>
+            </a:r>
+            <a:r>
+              <a:rPr lang="en-US" sz="2400" i="1" dirty="0">
+                <a:cs typeface="Arial" charset="0"/>
+                <a:sym typeface="Symbol" pitchFamily="18" charset="2"/>
+              </a:rPr>
+              <a:t>L</a:t>
+            </a:r>
+            <a:r>
+              <a:rPr lang="en-US" sz="2400" dirty="0">
+                <a:cs typeface="Arial" charset="0"/>
+                <a:sym typeface="Symbol" pitchFamily="18" charset="2"/>
+              </a:rPr>
+              <a:t>))</a:t>
+            </a:r>
+          </a:p>
+          <a:p>
+            <a:pPr eaLnBrk="1" hangingPunct="1"/>
+            <a:r>
+              <a:rPr lang="en-US" sz="2400" dirty="0">
+                <a:cs typeface="Arial" charset="0"/>
+                <a:sym typeface="Symbol" pitchFamily="18" charset="2"/>
+              </a:rPr>
+              <a:t>(</a:t>
+            </a:r>
+            <a:r>
+              <a:rPr lang="en-US" sz="2400" i="1" dirty="0">
+                <a:cs typeface="Arial" charset="0"/>
+                <a:sym typeface="Symbol" pitchFamily="18" charset="2"/>
+              </a:rPr>
+              <a:t>u</a:t>
+            </a:r>
+            <a:r>
+              <a:rPr lang="en-US" sz="2400" baseline="-25000" dirty="0">
+                <a:cs typeface="Arial" charset="0"/>
+                <a:sym typeface="Symbol" pitchFamily="18" charset="2"/>
+              </a:rPr>
+              <a:t>1</a:t>
+            </a:r>
+            <a:r>
+              <a:rPr lang="en-US" sz="2400" i="1" dirty="0">
+                <a:cs typeface="Arial" charset="0"/>
+                <a:sym typeface="Symbol" pitchFamily="18" charset="2"/>
+              </a:rPr>
+              <a:t>,u</a:t>
+            </a:r>
+            <a:r>
+              <a:rPr lang="en-US" sz="2400" baseline="-25000" dirty="0">
+                <a:cs typeface="Arial" charset="0"/>
+                <a:sym typeface="Symbol" pitchFamily="18" charset="2"/>
+              </a:rPr>
+              <a:t>2</a:t>
+            </a:r>
+            <a:r>
+              <a:rPr lang="en-US" sz="2400" dirty="0">
+                <a:cs typeface="Arial" charset="0"/>
+                <a:sym typeface="Symbol" pitchFamily="18" charset="2"/>
+              </a:rPr>
+              <a:t>)  </a:t>
+            </a:r>
+            <a:r>
+              <a:rPr lang="en-US" sz="2400" dirty="0" err="1">
+                <a:cs typeface="Arial" charset="0"/>
+                <a:sym typeface="Symbol" pitchFamily="18" charset="2"/>
+              </a:rPr>
+              <a:t>accept</a:t>
+            </a:r>
+            <a:r>
+              <a:rPr lang="en-US" sz="2400" i="1" baseline="-25000" dirty="0" err="1">
+                <a:cs typeface="Arial" charset="0"/>
+                <a:sym typeface="Symbol" pitchFamily="18" charset="2"/>
+              </a:rPr>
+              <a:t>BM</a:t>
+            </a:r>
+            <a:r>
+              <a:rPr lang="en-US" sz="2400" dirty="0">
+                <a:cs typeface="Arial" charset="0"/>
+                <a:sym typeface="Symbol" pitchFamily="18" charset="2"/>
+              </a:rPr>
+              <a:t>  </a:t>
+            </a:r>
+            <a:r>
+              <a:rPr lang="en-US" sz="2400" dirty="0">
+                <a:cs typeface="Arial" charset="0"/>
                 <a:sym typeface="Symbol"/>
               </a:rPr>
+              <a:t> </a:t>
+            </a:r>
+            <a:r>
+              <a:rPr lang="en-US" sz="2400" i="1" dirty="0">
+                <a:cs typeface="Arial" charset="0"/>
+                <a:sym typeface="Symbol" pitchFamily="18" charset="2"/>
+              </a:rPr>
+              <a:t> u</a:t>
+            </a:r>
+            <a:r>
+              <a:rPr lang="en-US" sz="2400" baseline="-25000" dirty="0">
+                <a:cs typeface="Arial" charset="0"/>
+                <a:sym typeface="Symbol" pitchFamily="18" charset="2"/>
+              </a:rPr>
+              <a:t>2</a:t>
+            </a:r>
+            <a:r>
+              <a:rPr lang="en-US" sz="2400" dirty="0">
+                <a:cs typeface="Arial" charset="0"/>
+                <a:sym typeface="Symbol" pitchFamily="18" charset="2"/>
+              </a:rPr>
+              <a:t>  </a:t>
+            </a:r>
+            <a:r>
+              <a:rPr lang="en-US" sz="2400" dirty="0" err="1">
+                <a:cs typeface="Arial" charset="0"/>
+                <a:sym typeface="Symbol" pitchFamily="18" charset="2"/>
+              </a:rPr>
+              <a:t>accept</a:t>
+            </a:r>
+            <a:r>
+              <a:rPr lang="en-US" sz="2400" baseline="-25000" dirty="0" err="1">
+                <a:cs typeface="Arial" charset="0"/>
+                <a:sym typeface="Symbol"/>
+              </a:rPr>
+              <a:t>B</a:t>
+            </a:r>
+            <a:r>
+              <a:rPr lang="en-US" sz="2400" baseline="-25000" dirty="0">
+                <a:cs typeface="Arial" charset="0"/>
+                <a:sym typeface="Symbol"/>
+              </a:rPr>
               <a:t></a:t>
-            </a:r>
-            <a:r>
-              <a:rPr lang="en-US" sz="2400" dirty="0">
-                <a:cs typeface="Arial" charset="0"/>
-                <a:sym typeface="Symbol" pitchFamily="18" charset="2"/>
-              </a:rPr>
-              <a:t>(</a:t>
-            </a:r>
-            <a:r>
-              <a:rPr lang="en-US" sz="2400" i="1" dirty="0">
-                <a:cs typeface="Arial" charset="0"/>
-                <a:sym typeface="Symbol" pitchFamily="18" charset="2"/>
-              </a:rPr>
-              <a:t>u</a:t>
-            </a:r>
-            <a:r>
-              <a:rPr lang="en-US" sz="2400" baseline="-25000" dirty="0">
-                <a:cs typeface="Arial" charset="0"/>
-                <a:sym typeface="Symbol" pitchFamily="18" charset="2"/>
-              </a:rPr>
-              <a:t>2</a:t>
-            </a:r>
-            <a:r>
-              <a:rPr lang="en-US" sz="2400" dirty="0">
-                <a:cs typeface="Arial" charset="0"/>
-                <a:sym typeface="Symbol" pitchFamily="18" charset="2"/>
-              </a:rPr>
-              <a:t>,</a:t>
-            </a:r>
-            <a:r>
-              <a:rPr lang="en-US" sz="2400" i="1" dirty="0">
-                <a:cs typeface="Arial" charset="0"/>
-                <a:sym typeface="Symbol" pitchFamily="18" charset="2"/>
-              </a:rPr>
-              <a:t>L</a:t>
-            </a:r>
-            <a:r>
-              <a:rPr lang="en-US" sz="2400" dirty="0">
-                <a:cs typeface="Arial" charset="0"/>
-                <a:sym typeface="Symbol" pitchFamily="18" charset="2"/>
-              </a:rPr>
-              <a:t>))</a:t>
-            </a:r>
-          </a:p>
-          <a:p>
-            <a:pPr eaLnBrk="1" hangingPunct="1"/>
-            <a:r>
-              <a:rPr lang="en-US" sz="2400" dirty="0">
-                <a:cs typeface="Arial" charset="0"/>
-                <a:sym typeface="Symbol" pitchFamily="18" charset="2"/>
-              </a:rPr>
-              <a:t>(</a:t>
-            </a:r>
-            <a:r>
-              <a:rPr lang="en-US" sz="2400" i="1" dirty="0">
-                <a:cs typeface="Arial" charset="0"/>
-                <a:sym typeface="Symbol" pitchFamily="18" charset="2"/>
-              </a:rPr>
-              <a:t>u</a:t>
-            </a:r>
-            <a:r>
-              <a:rPr lang="en-US" sz="2400" baseline="-25000" dirty="0">
-                <a:cs typeface="Arial" charset="0"/>
-                <a:sym typeface="Symbol" pitchFamily="18" charset="2"/>
-              </a:rPr>
-              <a:t>1</a:t>
-            </a:r>
-            <a:r>
-              <a:rPr lang="en-US" sz="2400" i="1" dirty="0">
-                <a:cs typeface="Arial" charset="0"/>
-                <a:sym typeface="Symbol" pitchFamily="18" charset="2"/>
-              </a:rPr>
-              <a:t>,u</a:t>
-            </a:r>
-            <a:r>
-              <a:rPr lang="en-US" sz="2400" baseline="-25000" dirty="0">
-                <a:cs typeface="Arial" charset="0"/>
-                <a:sym typeface="Symbol" pitchFamily="18" charset="2"/>
-              </a:rPr>
-              <a:t>2</a:t>
-            </a:r>
-            <a:r>
-              <a:rPr lang="en-US" sz="2400" dirty="0">
-                <a:cs typeface="Arial" charset="0"/>
-                <a:sym typeface="Symbol" pitchFamily="18" charset="2"/>
-              </a:rPr>
-              <a:t>)  </a:t>
-            </a:r>
-            <a:r>
-              <a:rPr lang="en-US" sz="2400" dirty="0" err="1">
-                <a:cs typeface="Arial" charset="0"/>
-                <a:sym typeface="Symbol" pitchFamily="18" charset="2"/>
-              </a:rPr>
-              <a:t>accept</a:t>
-            </a:r>
-            <a:r>
-              <a:rPr lang="en-US" sz="2400" i="1" baseline="-25000" dirty="0" err="1">
-                <a:cs typeface="Arial" charset="0"/>
-                <a:sym typeface="Symbol" pitchFamily="18" charset="2"/>
-              </a:rPr>
-              <a:t>C</a:t>
-            </a:r>
-            <a:r>
-              <a:rPr lang="en-US" sz="2400" dirty="0">
-                <a:cs typeface="Arial" charset="0"/>
-                <a:sym typeface="Symbol" pitchFamily="18" charset="2"/>
-              </a:rPr>
-              <a:t>  </a:t>
-            </a:r>
-            <a:r>
-              <a:rPr lang="en-US" sz="2400" dirty="0">
-                <a:cs typeface="Arial" charset="0"/>
-                <a:sym typeface="Symbol"/>
-              </a:rPr>
-              <a:t> </a:t>
-            </a:r>
-            <a:r>
-              <a:rPr lang="en-US" sz="2400" i="1" dirty="0">
-                <a:cs typeface="Arial" charset="0"/>
-                <a:sym typeface="Symbol" pitchFamily="18" charset="2"/>
-              </a:rPr>
-              <a:t> u</a:t>
-            </a:r>
-            <a:r>
-              <a:rPr lang="en-US" sz="2400" baseline="-25000" dirty="0">
-                <a:cs typeface="Arial" charset="0"/>
-                <a:sym typeface="Symbol" pitchFamily="18" charset="2"/>
-              </a:rPr>
-              <a:t>2</a:t>
-            </a:r>
-            <a:r>
-              <a:rPr lang="en-US" sz="2400" dirty="0">
-                <a:cs typeface="Arial" charset="0"/>
-                <a:sym typeface="Symbol" pitchFamily="18" charset="2"/>
-              </a:rPr>
-              <a:t>  accept</a:t>
-            </a:r>
-            <a:r>
-              <a:rPr lang="en-US" sz="2400" baseline="-25000" dirty="0">
-                <a:cs typeface="Arial" charset="0"/>
-                <a:sym typeface="Symbol"/>
-              </a:rPr>
-              <a:t> </a:t>
             </a:r>
             <a:r>
               <a:rPr lang="en-US" sz="2400" dirty="0">

</xml_diff>